<commit_message>
fix(forge): preserve unrepresentable text body geometry
</commit_message>
<xml_diff>
--- a/crates/forge-pptx/tests/fixtures/external.pptx
+++ b/crates/forge-pptx/tests/fixtures/external.pptx
@@ -3260,7 +3260,9 @@
         </p:nvSpPr>
         <p:spPr/>
         <p:txBody>
-          <a:bodyPr/>
+          <a:bodyPr lIns="0" rIns="0" tIns="0" bIns="0" wrap="square" anchor="t">
+            <a:noAutofit/>
+          </a:bodyPr>
           <a:lstStyle/>
           <a:p>
             <a:r>

</xml_diff>